<commit_message>
Giao diện mới cho prototype, dashboard, case study; README có ảnh; user flow 6 màn lõi
</commit_message>
<xml_diff>
--- a/08-package/S23-deck.pptx
+++ b/08-package/S23-deck.pptx
@@ -117,33 +117,33 @@
   <p:extLst>
     <p:ext uri="{521415D9-36F7-43E2-AB2F-B90AF26B5E84}">
       <p14:sectionLst xmlns:p14="http://schemas.microsoft.com/office/powerpoint/2010/main">
-        <p14:section name="Mở đầu" id="{5ead2e82-4372-2cbb-e677-2167d8cf8cef}">
+        <p14:section name="Mở đầu" id="{9248753c-376c-8072-3a32-4848a34a946c}">
           <p14:sldIdLst>
             <p14:sldId id="256"/>
             <p14:sldId id="257"/>
           </p14:sldIdLst>
         </p14:section>
-        <p14:section name="Phát hiện" id="{688d7f5d-9aa5-7115-b0d9-e87de6528609}">
+        <p14:section name="Phát hiện" id="{8a29e843-10a7-5229-967a-46efaecc9bd8}">
           <p14:sldIdLst>
             <p14:sldId id="258"/>
             <p14:sldId id="259"/>
             <p14:sldId id="260"/>
           </p14:sldIdLst>
         </p14:section>
-        <p14:section name="Giải pháp" id="{b4bc8298-8dfd-cdfc-99fd-deff996982a9}">
+        <p14:section name="Giải pháp" id="{3979a9cf-392c-0aa6-2518-34a864208f0a}">
           <p14:sldIdLst>
             <p14:sldId id="261"/>
             <p14:sldId id="262"/>
             <p14:sldId id="263"/>
           </p14:sldIdLst>
         </p14:section>
-        <p14:section name="Business case" id="{03b9df25-1c57-6927-bdf5-44a5a498fbb8}">
+        <p14:section name="Business case" id="{fd85379c-0bbf-5ad3-957b-a83b43d85811}">
           <p14:sldIdLst>
             <p14:sldId id="264"/>
             <p14:sldId id="265"/>
           </p14:sldIdLst>
         </p14:section>
-        <p14:section name="Kết" id="{b19adc4a-94ca-6fb7-91fe-1322d5d26811}">
+        <p14:section name="Kết" id="{535916c0-2280-c362-acff-27e024c989a6}">
           <p14:sldIdLst>
             <p14:sldId id="266"/>
           </p14:sldIdLst>

</xml_diff>

<commit_message>
Fs theo TT 07/2025 Phụ lục IXa (chì 18.278, pin sạc 54.876 đ/kg); xác minh Chỉ thị 20/CT-TTg; chạy lại business case
</commit_message>
<xml_diff>
--- a/08-package/S23-deck.pptx
+++ b/08-package/S23-deck.pptx
@@ -117,33 +117,33 @@
   <p:extLst>
     <p:ext uri="{521415D9-36F7-43E2-AB2F-B90AF26B5E84}">
       <p14:sectionLst xmlns:p14="http://schemas.microsoft.com/office/powerpoint/2010/main">
-        <p14:section name="Mở đầu" id="{9248753c-376c-8072-3a32-4848a34a946c}">
+        <p14:section name="Mở đầu" id="{d0bf0d08-698a-bcfc-81b1-561c606f015a}">
           <p14:sldIdLst>
             <p14:sldId id="256"/>
             <p14:sldId id="257"/>
           </p14:sldIdLst>
         </p14:section>
-        <p14:section name="Phát hiện" id="{8a29e843-10a7-5229-967a-46efaecc9bd8}">
+        <p14:section name="Phát hiện" id="{73341a5e-8ff8-d2dd-3d28-32159292ed21}">
           <p14:sldIdLst>
             <p14:sldId id="258"/>
             <p14:sldId id="259"/>
             <p14:sldId id="260"/>
           </p14:sldIdLst>
         </p14:section>
-        <p14:section name="Giải pháp" id="{3979a9cf-392c-0aa6-2518-34a864208f0a}">
+        <p14:section name="Giải pháp" id="{c12d1787-0cde-b1c2-db61-e0e99cbb2223}">
           <p14:sldIdLst>
             <p14:sldId id="261"/>
             <p14:sldId id="262"/>
             <p14:sldId id="263"/>
           </p14:sldIdLst>
         </p14:section>
-        <p14:section name="Business case" id="{fd85379c-0bbf-5ad3-957b-a83b43d85811}">
+        <p14:section name="Business case" id="{7df4f2b5-e6cb-92b2-eb4d-12521882698e}">
           <p14:sldIdLst>
             <p14:sldId id="264"/>
             <p14:sldId id="265"/>
           </p14:sldIdLst>
         </p14:section>
-        <p14:section name="Kết" id="{535916c0-2280-c362-acff-27e024c989a6}">
+        <p14:section name="Kết" id="{8b8c4fe0-65f1-d804-c8f2-a3e77303ab93}">
           <p14:sldIdLst>
             <p14:sldId id="266"/>
           </p14:sldIdLst>
@@ -346,7 +346,7 @@
                   <c:v>25.204</c:v>
                 </c:pt>
                 <c:pt idx="1">
-                  <c:v>19.187</c:v>
+                  <c:v>41.078</c:v>
                 </c:pt>
               </c:numCache>
             </c:numRef>
@@ -423,7 +423,7 @@
                   <c:v>19.202</c:v>
                 </c:pt>
                 <c:pt idx="1">
-                  <c:v>14.607</c:v>
+                  <c:v>31.026</c:v>
                 </c:pt>
               </c:numCache>
             </c:numRef>
@@ -1866,7 +1866,7 @@
           <a:p>
             <a:r>
               <a:rPr lang="en-US" dirty="0"/>
-              <a:t>2.000 lượt Monte Carlo. Pin Li theo dự thảo: A rẻ nhất 85,5%, C 14,5%. Theo chính sách 0%: A 60%, B 40%.</a:t>
+              <a:t>2.000 lượt Monte Carlo. Pin Li theo dự thảo: A rẻ nhất 97,0%, C 3,0%. Fs pin sạc 54.876 đ/kg theo TT 07/2025. Theo chính sách 0%: A 60%, B 40%.</a:t>
             </a:r>
             <a:endParaRPr lang="en-US" dirty="0"/>
           </a:p>
@@ -3412,7 +3412,7 @@
                   <a:schemeClr val="tx1"/>
                 </a:solidFill>
               </a:rPr>
-              <a:t>Quy tắc đổi hướng: giá pin đời thứ hai &lt; ~0,7 triệu đ/kWh hoặc tỷ lệ đủ điều kiện &lt; 20% → pin Li chuyển sang PRO</a:t>
+              <a:t>Quy tắc đổi hướng: giá pin đời thứ hai &lt; ~0,5 triệu đ/kWh hoặc tỷ lệ đủ điều kiện &lt; 20% → pin Li chuyển sang PRO</a:t>
             </a:r>
             <a:endParaRPr lang="en-US" sz="1600" dirty="0"/>
           </a:p>
@@ -8093,7 +8093,7 @@
                 <a:ea typeface="Cambria" pitchFamily="34" charset="-122"/>
                 <a:cs typeface="Cambria" pitchFamily="34" charset="-120"/>
               </a:rPr>
-              <a:t>0,67 tr</a:t>
+              <a:t>0,53 tr</a:t>
             </a:r>
             <a:endParaRPr lang="en-US" sz="3400" dirty="0"/>
           </a:p>
@@ -8129,7 +8129,7 @@
                   <a:schemeClr val="tx1"/>
                 </a:solidFill>
               </a:rPr>
-              <a:t>đ/kWh — giá pin đời thứ hai hòa vốn A = B cho pin Li</a:t>
+              <a:t>đ/kWh — giá pin đời thứ hai hòa vốn A = C cho pin Li (dự thảo)</a:t>
             </a:r>
             <a:endParaRPr lang="en-US" sz="1300" dirty="0"/>
           </a:p>

</xml_diff>